<commit_message>
docs: rewrite public materials in a natural voice
</commit_message>
<xml_diff>
--- a/competition/EraSeMap_RU.pptx
+++ b/competition/EraSeMap_RU.pptx
@@ -514,7 +514,7 @@
           <a:p>
             <a:r>
               <a:rPr lang="en-US" dirty="0"/>
-              <a:t>Начните с простой мысли: ответ DELETE 200 OK подтверждает только команду, но не исчезновение копий и производных. EraSeMap превращает обещание удаления в проверяемый путь.</a:t>
+              <a:t>Начните с простой мысли: ответ DELETE 200 OK подтверждает только команду, но не исчезновение копий и производных. EraSeMap проверяет весь путь данных.</a:t>
             </a:r>
             <a:endParaRPr lang="en-US" dirty="0"/>
           </a:p>
@@ -690,7 +690,7 @@
           <a:p>
             <a:r>
               <a:rPr lang="en-US" dirty="0"/>
-              <a:t>Поясните термины: retained utility — полезность для оставшихся пользователей; exact fallback — безопасное переобучение. Отрицательный результат здесь усиливает научную честность.</a:t>
+              <a:t>Поясните термины: retained utility — качество для оставшихся пользователей; exact fallback — полное переобучение. Отрицательный результат здесь важен, потому что система не скрывает проблему.</a:t>
             </a:r>
             <a:endParaRPr lang="en-US" dirty="0"/>
           </a:p>
@@ -1394,7 +1394,7 @@
           <a:p>
             <a:r>
               <a:rPr lang="en-US" dirty="0"/>
-              <a:t>Сравнение показывает эффективность после прохождения safety gates. Это нормализованная bounded задача, поэтому не переносите цифры автоматически на production.</a:t>
+              <a:t>Сравнение сделано после одинаковых обязательных проверок. Это ограниченная лабораторная задача, поэтому цифры нельзя автоматически переносить на рабочую систему.</a:t>
             </a:r>
             <a:endParaRPr lang="en-US" dirty="0"/>
           </a:p>
@@ -1482,7 +1482,7 @@
           <a:p>
             <a:r>
               <a:rPr lang="en-US" dirty="0"/>
-              <a:t>Активная проба выбирает следующий тест так, чтобы разделить оставшиеся гипотезы. Результат family-held-out показывает переносимость на новые семейства топологий, но не production deployment.</a:t>
+              <a:t>Активная проба выбирает следующий тест так, чтобы разделить оставшиеся гипотезы. Проверка на новых семействах топологий показывает перенос внутри эксперимента, но не доказывает готовность рабочей системы.</a:t>
             </a:r>
             <a:endParaRPr lang="en-US" dirty="0"/>
           </a:p>
@@ -1570,7 +1570,7 @@
           <a:p>
             <a:r>
               <a:rPr lang="en-US" dirty="0"/>
-              <a:t>Не скрывайте отрицательный model-unlearning результат. Сильная область проекта — evidence-led storage deletion; модельный канал доказывается отдельно. Подчеркните, что четыре строки не складываются в один рейтинг.</a:t>
+              <a:t>Не скрывайте отрицательный результат по модели. Основной результат проекта — проверка удаления в хранилищах; модельная ветка оценивается отдельно. Четыре строки на слайде нельзя складывать в один рейтинг.</a:t>
             </a:r>
             <a:endParaRPr lang="en-US" dirty="0"/>
           </a:p>
@@ -2227,7 +2227,7 @@
                 <a:ea typeface="Arial" pitchFamily="34" charset="-122"/>
                 <a:cs typeface="Arial" pitchFamily="34" charset="-120"/>
               </a:rPr>
-              <a:t>Это проверяемый путь.</a:t>
+              <a:t>Здесь проверяется весь путь.</a:t>
             </a:r>
             <a:endParaRPr lang="en-US" sz="2300" dirty="0"/>
           </a:p>
@@ -5115,7 +5115,7 @@
                 <a:ea typeface="Arial" pitchFamily="34" charset="-122"/>
                 <a:cs typeface="Arial" pitchFamily="34" charset="-120"/>
               </a:rPr>
-              <a:t>Честная граница: приближённое переобучение не считается успешным без проверки полезности.</a:t>
+              <a:t>Граница: быстрое переобучение не считается успешным без проверки качества для остальных.</a:t>
             </a:r>
             <a:endParaRPr lang="en-US" sz="1160" dirty="0"/>
           </a:p>
@@ -6405,7 +6405,7 @@
                 <a:ea typeface="Arial" pitchFamily="34" charset="-122"/>
                 <a:cs typeface="Arial" pitchFamily="34" charset="-120"/>
               </a:rPr>
-              <a:t>Сейчас: сильная воспроизводимость и ограниченные внешние данные.</a:t>
+              <a:t>Сейчас: воспроизводимый эксперимент и ограниченные внешние данные.</a:t>
             </a:r>
             <a:endParaRPr lang="en-US" sz="1070" dirty="0"/>
           </a:p>
@@ -6422,7 +6422,7 @@
                 <a:ea typeface="Arial" pitchFamily="34" charset="-122"/>
                 <a:cs typeface="Arial" pitchFamily="34" charset="-120"/>
               </a:rPr>
-              <a:t>Следующий честный шаг — независимая скрытая проверка.</a:t>
+              <a:t>Дальше нужна независимая скрытая проверка.</a:t>
             </a:r>
             <a:endParaRPr lang="en-US" sz="1070" dirty="0"/>
           </a:p>
@@ -6761,7 +6761,7 @@
                 <a:ea typeface="Arial" pitchFamily="34" charset="-122"/>
                 <a:cs typeface="Arial" pitchFamily="34" charset="-120"/>
               </a:rPr>
-              <a:t>в проверяемый, устойчивый во времени вердикт.</a:t>
+              <a:t>в процедуру с проверкой возврата во времени.</a:t>
             </a:r>
             <a:endParaRPr lang="en-US" sz="1650" dirty="0"/>
           </a:p>
@@ -10653,7 +10653,7 @@
                 <a:ea typeface="Arial" pitchFamily="34" charset="-122"/>
                 <a:cs typeface="Arial" pitchFamily="34" charset="-120"/>
               </a:rPr>
-              <a:t>Сильная система умеет сказать: INCOMPLETE</a:t>
+              <a:t>Система должна уметь сказать: INCOMPLETE</a:t>
             </a:r>
             <a:endParaRPr lang="en-US" sz="2700" dirty="0"/>
           </a:p>
@@ -10692,7 +10692,7 @@
                 <a:ea typeface="Arial" pitchFamily="34" charset="-122"/>
                 <a:cs typeface="Arial" pitchFamily="34" charset="-120"/>
               </a:rPr>
-              <a:t>Если путь ещё активен, EraSeMap не выдаёт ложную уверенность.</a:t>
+              <a:t>Если путь ещё активен, EraSeMap не объявляет удаление завершённым.</a:t>
             </a:r>
             <a:endParaRPr lang="en-US" sz="1330" dirty="0"/>
           </a:p>

</xml_diff>